<commit_message>
docs: update presentation slides and project report files
</commit_message>
<xml_diff>
--- a/Cloud_Computing_Capstone_Khmer.pptx
+++ b/Cloud_Computing_Capstone_Khmer.pptx
@@ -3153,8 +3153,8 @@
         </p:nvSpPr>
         <p:spPr>
           <a:xfrm>
-            <a:off x="914400" y="1371600"/>
-            <a:ext cx="10362895" cy="2600712"/>
+            <a:off x="914552" y="1371600"/>
+            <a:ext cx="10362895" cy="3985706"/>
           </a:xfrm>
           <a:prstGeom prst="rect">
             <a:avLst/>
@@ -3301,6 +3301,9 @@
             </a:pPr>
             <a:r>
               <a:rPr dirty="0" err="1">
+                <a:solidFill>
+                  <a:schemeClr val="bg1"/>
+                </a:solidFill>
                 <a:latin typeface="AKbalthom KhmerNew" panose="02000500000000000000" pitchFamily="2" charset="0"/>
                 <a:cs typeface="AKbalthom KhmerNew" panose="02000500000000000000" pitchFamily="2" charset="0"/>
               </a:rPr>
@@ -3308,27 +3311,19 @@
             </a:r>
             <a:r>
               <a:rPr dirty="0">
-                <a:latin typeface="AKbalthom KhmerNew" panose="02000500000000000000" pitchFamily="2" charset="0"/>
-                <a:cs typeface="AKbalthom KhmerNew" panose="02000500000000000000" pitchFamily="2" charset="0"/>
-              </a:rPr>
-              <a:t> / </a:t>
+                <a:solidFill>
+                  <a:schemeClr val="bg1"/>
+                </a:solidFill>
+                <a:latin typeface="AKbalthom KhmerNew" panose="02000500000000000000" pitchFamily="2" charset="0"/>
+                <a:cs typeface="AKbalthom KhmerNew" panose="02000500000000000000" pitchFamily="2" charset="0"/>
+              </a:rPr>
+              <a:t> : Chamroeun Saran  |  </a:t>
             </a:r>
             <a:r>
               <a:rPr dirty="0" err="1">
-                <a:latin typeface="AKbalthom KhmerNew" panose="02000500000000000000" pitchFamily="2" charset="0"/>
-                <a:cs typeface="AKbalthom KhmerNew" panose="02000500000000000000" pitchFamily="2" charset="0"/>
-              </a:rPr>
-              <a:t>វិស្វករ</a:t>
-            </a:r>
-            <a:r>
-              <a:rPr dirty="0">
-                <a:latin typeface="AKbalthom KhmerNew" panose="02000500000000000000" pitchFamily="2" charset="0"/>
-                <a:cs typeface="AKbalthom KhmerNew" panose="02000500000000000000" pitchFamily="2" charset="0"/>
-              </a:rPr>
-              <a:t>: Chamroeun Saran  |  </a:t>
-            </a:r>
-            <a:r>
-              <a:rPr dirty="0" err="1">
+                <a:solidFill>
+                  <a:schemeClr val="bg1"/>
+                </a:solidFill>
                 <a:latin typeface="AKbalthom KhmerNew" panose="02000500000000000000" pitchFamily="2" charset="0"/>
                 <a:cs typeface="AKbalthom KhmerNew" panose="02000500000000000000" pitchFamily="2" charset="0"/>
               </a:rPr>
@@ -3336,6 +3331,9 @@
             </a:r>
             <a:r>
               <a:rPr dirty="0">
+                <a:solidFill>
+                  <a:schemeClr val="bg1"/>
+                </a:solidFill>
                 <a:latin typeface="AKbalthom KhmerNew" panose="02000500000000000000" pitchFamily="2" charset="0"/>
                 <a:cs typeface="AKbalthom KhmerNew" panose="02000500000000000000" pitchFamily="2" charset="0"/>
               </a:rPr>
@@ -3355,6 +3353,9 @@
             </a:pPr>
             <a:r>
               <a:rPr dirty="0">
+                <a:solidFill>
+                  <a:schemeClr val="bg1"/>
+                </a:solidFill>
                 <a:latin typeface="AKbalthom KhmerNew" panose="02000500000000000000" pitchFamily="2" charset="0"/>
                 <a:cs typeface="AKbalthom KhmerNew" panose="02000500000000000000" pitchFamily="2" charset="0"/>
               </a:rPr>
@@ -3374,6 +3375,9 @@
             </a:pPr>
             <a:r>
               <a:rPr dirty="0" err="1">
+                <a:solidFill>
+                  <a:schemeClr val="bg1"/>
+                </a:solidFill>
                 <a:latin typeface="AKbalthom KhmerNew" panose="02000500000000000000" pitchFamily="2" charset="0"/>
                 <a:cs typeface="AKbalthom KhmerNew" panose="02000500000000000000" pitchFamily="2" charset="0"/>
               </a:rPr>
@@ -3381,10 +3385,177 @@
             </a:r>
             <a:r>
               <a:rPr dirty="0">
-                <a:latin typeface="AKbalthom KhmerNew" panose="02000500000000000000" pitchFamily="2" charset="0"/>
-                <a:cs typeface="AKbalthom KhmerNew" panose="02000500000000000000" pitchFamily="2" charset="0"/>
-              </a:rPr>
-              <a:t>់: Jenkins Pipeline #4 Passed  |  Live Cluster IP: 54.253.170.114  |  October 2026</a:t>
+                <a:solidFill>
+                  <a:schemeClr val="bg1"/>
+                </a:solidFill>
+                <a:latin typeface="AKbalthom KhmerNew" panose="02000500000000000000" pitchFamily="2" charset="0"/>
+                <a:cs typeface="AKbalthom KhmerNew" panose="02000500000000000000" pitchFamily="2" charset="0"/>
+              </a:rPr>
+              <a:t>់: Jenkins Pipeline #4 Passed  |  Live Cluster IP: </a:t>
+            </a:r>
+            <a:r>
+              <a:rPr lang="en-US" dirty="0">
+                <a:solidFill>
+                  <a:schemeClr val="bg1"/>
+                </a:solidFill>
+                <a:latin typeface="AKbalthom KhmerNew" panose="02000500000000000000" pitchFamily="2" charset="0"/>
+                <a:cs typeface="AKbalthom KhmerNew" panose="02000500000000000000" pitchFamily="2" charset="0"/>
+              </a:rPr>
+              <a:t>http://16.178.178.44/</a:t>
+            </a:r>
+            <a:r>
+              <a:rPr dirty="0">
+                <a:solidFill>
+                  <a:schemeClr val="bg1"/>
+                </a:solidFill>
+                <a:latin typeface="AKbalthom KhmerNew" panose="02000500000000000000" pitchFamily="2" charset="0"/>
+                <a:cs typeface="AKbalthom KhmerNew" panose="02000500000000000000" pitchFamily="2" charset="0"/>
+              </a:rPr>
+              <a:t>  |  </a:t>
+            </a:r>
+            <a:r>
+              <a:rPr lang="en-GB" dirty="0">
+                <a:solidFill>
+                  <a:schemeClr val="bg1"/>
+                </a:solidFill>
+                <a:latin typeface="AKbalthom KhmerNew" panose="02000500000000000000" pitchFamily="2" charset="0"/>
+                <a:cs typeface="AKbalthom KhmerNew" panose="02000500000000000000" pitchFamily="2" charset="0"/>
+              </a:rPr>
+              <a:t>31 </a:t>
+            </a:r>
+            <a:r>
+              <a:rPr>
+                <a:solidFill>
+                  <a:schemeClr val="bg1"/>
+                </a:solidFill>
+                <a:latin typeface="AKbalthom KhmerNew" panose="02000500000000000000" pitchFamily="2" charset="0"/>
+                <a:cs typeface="AKbalthom KhmerNew" panose="02000500000000000000" pitchFamily="2" charset="0"/>
+              </a:rPr>
+              <a:t>October </a:t>
+            </a:r>
+            <a:r>
+              <a:rPr dirty="0">
+                <a:solidFill>
+                  <a:schemeClr val="bg1"/>
+                </a:solidFill>
+                <a:latin typeface="AKbalthom KhmerNew" panose="02000500000000000000" pitchFamily="2" charset="0"/>
+                <a:cs typeface="AKbalthom KhmerNew" panose="02000500000000000000" pitchFamily="2" charset="0"/>
+              </a:rPr>
+              <a:t>2026</a:t>
+            </a:r>
+            <a:endParaRPr lang="en-GB" dirty="0">
+              <a:solidFill>
+                <a:schemeClr val="bg1"/>
+              </a:solidFill>
+              <a:latin typeface="AKbalthom KhmerNew" panose="02000500000000000000" pitchFamily="2" charset="0"/>
+              <a:cs typeface="AKbalthom KhmerNew" panose="02000500000000000000" pitchFamily="2" charset="0"/>
+            </a:endParaRPr>
+          </a:p>
+          <a:p>
+            <a:pPr>
+              <a:spcBef>
+                <a:spcPts val="600"/>
+              </a:spcBef>
+              <a:defRPr sz="1300">
+                <a:solidFill>
+                  <a:srgbClr val="94A3B8"/>
+                </a:solidFill>
+              </a:defRPr>
+            </a:pPr>
+            <a:endParaRPr lang="en-US" dirty="0">
+              <a:solidFill>
+                <a:schemeClr val="bg1"/>
+              </a:solidFill>
+              <a:latin typeface="AKbalthom KhmerNew" panose="02000500000000000000" pitchFamily="2" charset="0"/>
+              <a:cs typeface="AKbalthom KhmerNew" panose="02000500000000000000" pitchFamily="2" charset="0"/>
+            </a:endParaRPr>
+          </a:p>
+          <a:p>
+            <a:pPr>
+              <a:spcBef>
+                <a:spcPts val="600"/>
+              </a:spcBef>
+              <a:defRPr sz="1300">
+                <a:solidFill>
+                  <a:srgbClr val="94A3B8"/>
+                </a:solidFill>
+              </a:defRPr>
+            </a:pPr>
+            <a:r>
+              <a:rPr lang="en-US" b="1" dirty="0">
+                <a:solidFill>
+                  <a:schemeClr val="bg1"/>
+                </a:solidFill>
+                <a:latin typeface="AKbalthom KhmerNew" panose="02000500000000000000" pitchFamily="2" charset="0"/>
+                <a:cs typeface="AKbalthom KhmerNew" panose="02000500000000000000" pitchFamily="2" charset="0"/>
+              </a:rPr>
+              <a:t>Group1:</a:t>
+            </a:r>
+          </a:p>
+          <a:p>
+            <a:pPr>
+              <a:spcBef>
+                <a:spcPts val="600"/>
+              </a:spcBef>
+              <a:defRPr sz="1300">
+                <a:solidFill>
+                  <a:srgbClr val="94A3B8"/>
+                </a:solidFill>
+              </a:defRPr>
+            </a:pPr>
+            <a:r>
+              <a:rPr lang="en-US" b="1" dirty="0">
+                <a:solidFill>
+                  <a:schemeClr val="bg1"/>
+                </a:solidFill>
+                <a:latin typeface="AKbalthom KhmerNew" panose="02000500000000000000" pitchFamily="2" charset="0"/>
+                <a:cs typeface="AKbalthom KhmerNew" panose="02000500000000000000" pitchFamily="2" charset="0"/>
+              </a:rPr>
+              <a:t>	SARAN CHAMROEUN</a:t>
+            </a:r>
+          </a:p>
+          <a:p>
+            <a:pPr>
+              <a:spcBef>
+                <a:spcPts val="600"/>
+              </a:spcBef>
+              <a:defRPr sz="1300">
+                <a:solidFill>
+                  <a:srgbClr val="94A3B8"/>
+                </a:solidFill>
+              </a:defRPr>
+            </a:pPr>
+            <a:r>
+              <a:rPr lang="en-US" b="1" dirty="0">
+                <a:solidFill>
+                  <a:schemeClr val="bg1"/>
+                </a:solidFill>
+                <a:latin typeface="AKbalthom KhmerNew" panose="02000500000000000000" pitchFamily="2" charset="0"/>
+                <a:cs typeface="AKbalthom KhmerNew" panose="02000500000000000000" pitchFamily="2" charset="0"/>
+              </a:rPr>
+              <a:t>	SOM LIHENG</a:t>
+            </a:r>
+          </a:p>
+          <a:p>
+            <a:pPr>
+              <a:spcBef>
+                <a:spcPts val="600"/>
+              </a:spcBef>
+              <a:defRPr sz="1300">
+                <a:solidFill>
+                  <a:srgbClr val="94A3B8"/>
+                </a:solidFill>
+              </a:defRPr>
+            </a:pPr>
+            <a:r>
+              <a:rPr lang="en-US" b="1" dirty="0">
+                <a:solidFill>
+                  <a:schemeClr val="bg1"/>
+                </a:solidFill>
+                <a:latin typeface="AKbalthom KhmerNew" panose="02000500000000000000" pitchFamily="2" charset="0"/>
+                <a:cs typeface="AKbalthom KhmerNew" panose="02000500000000000000" pitchFamily="2" charset="0"/>
+              </a:rPr>
+              <a:t>	NGY LYTENG</a:t>
             </a:r>
           </a:p>
         </p:txBody>
@@ -4744,7 +4915,14 @@
                 <a:latin typeface="AKbalthom KhmerNew" panose="02000500000000000000" pitchFamily="2" charset="0"/>
                 <a:cs typeface="AKbalthom KhmerNew" panose="02000500000000000000" pitchFamily="2" charset="0"/>
               </a:rPr>
-              <a:t> http://54.253.170.114 </a:t>
+              <a:t> </a:t>
+            </a:r>
+            <a:r>
+              <a:rPr lang="en-US" dirty="0">
+                <a:latin typeface="AKbalthom KhmerNew" panose="02000500000000000000" pitchFamily="2" charset="0"/>
+                <a:cs typeface="AKbalthom KhmerNew" panose="02000500000000000000" pitchFamily="2" charset="0"/>
+              </a:rPr>
+              <a:t>http://16.178.178.44/</a:t>
             </a:r>
             <a:r>
               <a:rPr dirty="0" err="1">
@@ -4854,11 +5032,25 @@
               </a:defRPr>
             </a:pPr>
             <a:r>
-              <a:rPr>
-                <a:latin typeface="AKbalthom KhmerNew" panose="02000500000000000000" pitchFamily="2" charset="0"/>
-                <a:cs typeface="AKbalthom KhmerNew" panose="02000500000000000000" pitchFamily="2" charset="0"/>
-              </a:rPr>
-              <a:t>💻  ជំហានទី ២: HTTP Endpoint Verification</a:t>
+              <a:rPr dirty="0">
+                <a:latin typeface="AKbalthom KhmerNew" panose="02000500000000000000" pitchFamily="2" charset="0"/>
+                <a:cs typeface="AKbalthom KhmerNew" panose="02000500000000000000" pitchFamily="2" charset="0"/>
+              </a:rPr>
+              <a:t>💻  </a:t>
+            </a:r>
+            <a:r>
+              <a:rPr dirty="0" err="1">
+                <a:latin typeface="AKbalthom KhmerNew" panose="02000500000000000000" pitchFamily="2" charset="0"/>
+                <a:cs typeface="AKbalthom KhmerNew" panose="02000500000000000000" pitchFamily="2" charset="0"/>
+              </a:rPr>
+              <a:t>ជំហានទី</a:t>
+            </a:r>
+            <a:r>
+              <a:rPr dirty="0">
+                <a:latin typeface="AKbalthom KhmerNew" panose="02000500000000000000" pitchFamily="2" charset="0"/>
+                <a:cs typeface="AKbalthom KhmerNew" panose="02000500000000000000" pitchFamily="2" charset="0"/>
+              </a:rPr>
+              <a:t> ២: HTTP Endpoint Verification</a:t>
             </a:r>
           </a:p>
           <a:p>
@@ -4873,11 +5065,60 @@
               </a:defRPr>
             </a:pPr>
             <a:r>
-              <a:rPr>
-                <a:latin typeface="AKbalthom KhmerNew" panose="02000500000000000000" pitchFamily="2" charset="0"/>
-                <a:cs typeface="AKbalthom KhmerNew" panose="02000500000000000000" pitchFamily="2" charset="0"/>
-              </a:rPr>
-              <a:t>តេស្ត curl -s /health, curl -s /api/info (បង្ហាញ round-robin), និង curl -s /nginx-health</a:t>
+              <a:rPr dirty="0" err="1">
+                <a:latin typeface="AKbalthom KhmerNew" panose="02000500000000000000" pitchFamily="2" charset="0"/>
+                <a:cs typeface="AKbalthom KhmerNew" panose="02000500000000000000" pitchFamily="2" charset="0"/>
+              </a:rPr>
+              <a:t>តេស្ត</a:t>
+            </a:r>
+            <a:r>
+              <a:rPr dirty="0">
+                <a:latin typeface="AKbalthom KhmerNew" panose="02000500000000000000" pitchFamily="2" charset="0"/>
+                <a:cs typeface="AKbalthom KhmerNew" panose="02000500000000000000" pitchFamily="2" charset="0"/>
+              </a:rPr>
+              <a:t> curl -s /health, curl -s /</a:t>
+            </a:r>
+            <a:r>
+              <a:rPr dirty="0" err="1">
+                <a:latin typeface="AKbalthom KhmerNew" panose="02000500000000000000" pitchFamily="2" charset="0"/>
+                <a:cs typeface="AKbalthom KhmerNew" panose="02000500000000000000" pitchFamily="2" charset="0"/>
+              </a:rPr>
+              <a:t>api</a:t>
+            </a:r>
+            <a:r>
+              <a:rPr dirty="0">
+                <a:latin typeface="AKbalthom KhmerNew" panose="02000500000000000000" pitchFamily="2" charset="0"/>
+                <a:cs typeface="AKbalthom KhmerNew" panose="02000500000000000000" pitchFamily="2" charset="0"/>
+              </a:rPr>
+              <a:t>/info (</a:t>
+            </a:r>
+            <a:r>
+              <a:rPr dirty="0" err="1">
+                <a:latin typeface="AKbalthom KhmerNew" panose="02000500000000000000" pitchFamily="2" charset="0"/>
+                <a:cs typeface="AKbalthom KhmerNew" panose="02000500000000000000" pitchFamily="2" charset="0"/>
+              </a:rPr>
+              <a:t>បង្ហាញ</a:t>
+            </a:r>
+            <a:r>
+              <a:rPr dirty="0">
+                <a:latin typeface="AKbalthom KhmerNew" panose="02000500000000000000" pitchFamily="2" charset="0"/>
+                <a:cs typeface="AKbalthom KhmerNew" panose="02000500000000000000" pitchFamily="2" charset="0"/>
+              </a:rPr>
+              <a:t> round-robin), </a:t>
+            </a:r>
+            <a:r>
+              <a:rPr dirty="0" err="1">
+                <a:latin typeface="AKbalthom KhmerNew" panose="02000500000000000000" pitchFamily="2" charset="0"/>
+                <a:cs typeface="AKbalthom KhmerNew" panose="02000500000000000000" pitchFamily="2" charset="0"/>
+              </a:rPr>
+              <a:t>និង</a:t>
+            </a:r>
+            <a:r>
+              <a:rPr dirty="0">
+                <a:latin typeface="AKbalthom KhmerNew" panose="02000500000000000000" pitchFamily="2" charset="0"/>
+                <a:cs typeface="AKbalthom KhmerNew" panose="02000500000000000000" pitchFamily="2" charset="0"/>
+              </a:rPr>
+              <a:t> curl -s /nginx-health</a:t>
             </a:r>
           </a:p>
         </p:txBody>
@@ -4931,11 +5172,25 @@
               </a:defRPr>
             </a:pPr>
             <a:r>
-              <a:rPr>
-                <a:latin typeface="AKbalthom KhmerNew" panose="02000500000000000000" pitchFamily="2" charset="0"/>
-                <a:cs typeface="AKbalthom KhmerNew" panose="02000500000000000000" pitchFamily="2" charset="0"/>
-              </a:rPr>
-              <a:t>💻  ជំហានទី ៣: Jenkins CI/CD Automation</a:t>
+              <a:rPr dirty="0">
+                <a:latin typeface="AKbalthom KhmerNew" panose="02000500000000000000" pitchFamily="2" charset="0"/>
+                <a:cs typeface="AKbalthom KhmerNew" panose="02000500000000000000" pitchFamily="2" charset="0"/>
+              </a:rPr>
+              <a:t>💻  </a:t>
+            </a:r>
+            <a:r>
+              <a:rPr dirty="0" err="1">
+                <a:latin typeface="AKbalthom KhmerNew" panose="02000500000000000000" pitchFamily="2" charset="0"/>
+                <a:cs typeface="AKbalthom KhmerNew" panose="02000500000000000000" pitchFamily="2" charset="0"/>
+              </a:rPr>
+              <a:t>ជំហានទី</a:t>
+            </a:r>
+            <a:r>
+              <a:rPr dirty="0">
+                <a:latin typeface="AKbalthom KhmerNew" panose="02000500000000000000" pitchFamily="2" charset="0"/>
+                <a:cs typeface="AKbalthom KhmerNew" panose="02000500000000000000" pitchFamily="2" charset="0"/>
+              </a:rPr>
+              <a:t> ៣: Jenkins CI/CD Automation</a:t>
             </a:r>
           </a:p>
           <a:p>
@@ -4950,11 +5205,74 @@
               </a:defRPr>
             </a:pPr>
             <a:r>
-              <a:rPr>
-                <a:latin typeface="AKbalthom KhmerNew" panose="02000500000000000000" pitchFamily="2" charset="0"/>
-                <a:cs typeface="AKbalthom KhmerNew" panose="02000500000000000000" pitchFamily="2" charset="0"/>
-              </a:rPr>
-              <a:t>បើក Jenkins console បង្ហាញ Build #4 Stage View ពណ៌បៃតងទាំង ៥ ព្រមទាំង Pytest (5/5) &amp; Flake8</a:t>
+              <a:rPr dirty="0" err="1">
+                <a:latin typeface="AKbalthom KhmerNew" panose="02000500000000000000" pitchFamily="2" charset="0"/>
+                <a:cs typeface="AKbalthom KhmerNew" panose="02000500000000000000" pitchFamily="2" charset="0"/>
+              </a:rPr>
+              <a:t>បើក</a:t>
+            </a:r>
+            <a:r>
+              <a:rPr dirty="0">
+                <a:latin typeface="AKbalthom KhmerNew" panose="02000500000000000000" pitchFamily="2" charset="0"/>
+                <a:cs typeface="AKbalthom KhmerNew" panose="02000500000000000000" pitchFamily="2" charset="0"/>
+              </a:rPr>
+              <a:t> Jenkins console </a:t>
+            </a:r>
+            <a:r>
+              <a:rPr dirty="0" err="1">
+                <a:latin typeface="AKbalthom KhmerNew" panose="02000500000000000000" pitchFamily="2" charset="0"/>
+                <a:cs typeface="AKbalthom KhmerNew" panose="02000500000000000000" pitchFamily="2" charset="0"/>
+              </a:rPr>
+              <a:t>បង្ហាញ</a:t>
+            </a:r>
+            <a:r>
+              <a:rPr dirty="0">
+                <a:latin typeface="AKbalthom KhmerNew" panose="02000500000000000000" pitchFamily="2" charset="0"/>
+                <a:cs typeface="AKbalthom KhmerNew" panose="02000500000000000000" pitchFamily="2" charset="0"/>
+              </a:rPr>
+              <a:t> Build # Stage View </a:t>
+            </a:r>
+            <a:r>
+              <a:rPr dirty="0" err="1">
+                <a:latin typeface="AKbalthom KhmerNew" panose="02000500000000000000" pitchFamily="2" charset="0"/>
+                <a:cs typeface="AKbalthom KhmerNew" panose="02000500000000000000" pitchFamily="2" charset="0"/>
+              </a:rPr>
+              <a:t>ពណ៌បៃតងទាំង</a:t>
+            </a:r>
+            <a:r>
+              <a:rPr dirty="0">
+                <a:latin typeface="AKbalthom KhmerNew" panose="02000500000000000000" pitchFamily="2" charset="0"/>
+                <a:cs typeface="AKbalthom KhmerNew" panose="02000500000000000000" pitchFamily="2" charset="0"/>
+              </a:rPr>
+              <a:t> ៥ </a:t>
+            </a:r>
+            <a:r>
+              <a:rPr dirty="0" err="1">
+                <a:latin typeface="AKbalthom KhmerNew" panose="02000500000000000000" pitchFamily="2" charset="0"/>
+                <a:cs typeface="AKbalthom KhmerNew" panose="02000500000000000000" pitchFamily="2" charset="0"/>
+              </a:rPr>
+              <a:t>ព្រមទាំង</a:t>
+            </a:r>
+            <a:r>
+              <a:rPr dirty="0">
+                <a:latin typeface="AKbalthom KhmerNew" panose="02000500000000000000" pitchFamily="2" charset="0"/>
+                <a:cs typeface="AKbalthom KhmerNew" panose="02000500000000000000" pitchFamily="2" charset="0"/>
+              </a:rPr>
+              <a:t> </a:t>
+            </a:r>
+            <a:r>
+              <a:rPr dirty="0" err="1">
+                <a:latin typeface="AKbalthom KhmerNew" panose="02000500000000000000" pitchFamily="2" charset="0"/>
+                <a:cs typeface="AKbalthom KhmerNew" panose="02000500000000000000" pitchFamily="2" charset="0"/>
+              </a:rPr>
+              <a:t>Pytest</a:t>
+            </a:r>
+            <a:r>
+              <a:rPr dirty="0">
+                <a:latin typeface="AKbalthom KhmerNew" panose="02000500000000000000" pitchFamily="2" charset="0"/>
+                <a:cs typeface="AKbalthom KhmerNew" panose="02000500000000000000" pitchFamily="2" charset="0"/>
+              </a:rPr>
+              <a:t> (5/5) &amp; Flake8</a:t>
             </a:r>
           </a:p>
         </p:txBody>
@@ -5008,11 +5326,25 @@
               </a:defRPr>
             </a:pPr>
             <a:r>
-              <a:rPr>
-                <a:latin typeface="AKbalthom KhmerNew" panose="02000500000000000000" pitchFamily="2" charset="0"/>
-                <a:cs typeface="AKbalthom KhmerNew" panose="02000500000000000000" pitchFamily="2" charset="0"/>
-              </a:rPr>
-              <a:t>💻  ជំហានទី ៤: Docker Swarm Cluster via SSH</a:t>
+              <a:rPr dirty="0">
+                <a:latin typeface="AKbalthom KhmerNew" panose="02000500000000000000" pitchFamily="2" charset="0"/>
+                <a:cs typeface="AKbalthom KhmerNew" panose="02000500000000000000" pitchFamily="2" charset="0"/>
+              </a:rPr>
+              <a:t>💻  </a:t>
+            </a:r>
+            <a:r>
+              <a:rPr dirty="0" err="1">
+                <a:latin typeface="AKbalthom KhmerNew" panose="02000500000000000000" pitchFamily="2" charset="0"/>
+                <a:cs typeface="AKbalthom KhmerNew" panose="02000500000000000000" pitchFamily="2" charset="0"/>
+              </a:rPr>
+              <a:t>ជំហានទី</a:t>
+            </a:r>
+            <a:r>
+              <a:rPr dirty="0">
+                <a:latin typeface="AKbalthom KhmerNew" panose="02000500000000000000" pitchFamily="2" charset="0"/>
+                <a:cs typeface="AKbalthom KhmerNew" panose="02000500000000000000" pitchFamily="2" charset="0"/>
+              </a:rPr>
+              <a:t> ៤: Docker Swarm Cluster via SSH</a:t>
             </a:r>
           </a:p>
           <a:p>
@@ -5027,11 +5359,95 @@
               </a:defRPr>
             </a:pPr>
             <a:r>
-              <a:rPr>
-                <a:latin typeface="AKbalthom KhmerNew" panose="02000500000000000000" pitchFamily="2" charset="0"/>
-                <a:cs typeface="AKbalthom KhmerNew" panose="02000500000000000000" pitchFamily="2" charset="0"/>
-              </a:rPr>
-              <a:t>SSH ទៅកាន់ Manager node ដំណើរការ 'docker service ls' (2/2 replicas) និង 'docker stack ps' បង្ហាញការចែកចាយ nodes</a:t>
+              <a:rPr dirty="0">
+                <a:latin typeface="AKbalthom KhmerNew" panose="02000500000000000000" pitchFamily="2" charset="0"/>
+                <a:cs typeface="AKbalthom KhmerNew" panose="02000500000000000000" pitchFamily="2" charset="0"/>
+              </a:rPr>
+              <a:t>SSH </a:t>
+            </a:r>
+            <a:r>
+              <a:rPr dirty="0" err="1">
+                <a:latin typeface="AKbalthom KhmerNew" panose="02000500000000000000" pitchFamily="2" charset="0"/>
+                <a:cs typeface="AKbalthom KhmerNew" panose="02000500000000000000" pitchFamily="2" charset="0"/>
+              </a:rPr>
+              <a:t>ទៅកាន</a:t>
+            </a:r>
+            <a:r>
+              <a:rPr dirty="0">
+                <a:latin typeface="AKbalthom KhmerNew" panose="02000500000000000000" pitchFamily="2" charset="0"/>
+                <a:cs typeface="AKbalthom KhmerNew" panose="02000500000000000000" pitchFamily="2" charset="0"/>
+              </a:rPr>
+              <a:t>់ Manager node </a:t>
+            </a:r>
+            <a:r>
+              <a:rPr dirty="0" err="1">
+                <a:latin typeface="AKbalthom KhmerNew" panose="02000500000000000000" pitchFamily="2" charset="0"/>
+                <a:cs typeface="AKbalthom KhmerNew" panose="02000500000000000000" pitchFamily="2" charset="0"/>
+              </a:rPr>
+              <a:t>ដំណើរការ</a:t>
+            </a:r>
+            <a:r>
+              <a:rPr dirty="0">
+                <a:latin typeface="AKbalthom KhmerNew" panose="02000500000000000000" pitchFamily="2" charset="0"/>
+                <a:cs typeface="AKbalthom KhmerNew" panose="02000500000000000000" pitchFamily="2" charset="0"/>
+              </a:rPr>
+              <a:t> 'docker service </a:t>
+            </a:r>
+            <a:r>
+              <a:rPr dirty="0" err="1">
+                <a:latin typeface="AKbalthom KhmerNew" panose="02000500000000000000" pitchFamily="2" charset="0"/>
+                <a:cs typeface="AKbalthom KhmerNew" panose="02000500000000000000" pitchFamily="2" charset="0"/>
+              </a:rPr>
+              <a:t>ls'</a:t>
+            </a:r>
+            <a:r>
+              <a:rPr dirty="0">
+                <a:latin typeface="AKbalthom KhmerNew" panose="02000500000000000000" pitchFamily="2" charset="0"/>
+                <a:cs typeface="AKbalthom KhmerNew" panose="02000500000000000000" pitchFamily="2" charset="0"/>
+              </a:rPr>
+              <a:t> (2/2 replicas) </a:t>
+            </a:r>
+            <a:r>
+              <a:rPr dirty="0" err="1">
+                <a:latin typeface="AKbalthom KhmerNew" panose="02000500000000000000" pitchFamily="2" charset="0"/>
+                <a:cs typeface="AKbalthom KhmerNew" panose="02000500000000000000" pitchFamily="2" charset="0"/>
+              </a:rPr>
+              <a:t>និង</a:t>
+            </a:r>
+            <a:r>
+              <a:rPr dirty="0">
+                <a:latin typeface="AKbalthom KhmerNew" panose="02000500000000000000" pitchFamily="2" charset="0"/>
+                <a:cs typeface="AKbalthom KhmerNew" panose="02000500000000000000" pitchFamily="2" charset="0"/>
+              </a:rPr>
+              <a:t> 'docker stack </a:t>
+            </a:r>
+            <a:r>
+              <a:rPr dirty="0" err="1">
+                <a:latin typeface="AKbalthom KhmerNew" panose="02000500000000000000" pitchFamily="2" charset="0"/>
+                <a:cs typeface="AKbalthom KhmerNew" panose="02000500000000000000" pitchFamily="2" charset="0"/>
+              </a:rPr>
+              <a:t>ps'</a:t>
+            </a:r>
+            <a:r>
+              <a:rPr dirty="0">
+                <a:latin typeface="AKbalthom KhmerNew" panose="02000500000000000000" pitchFamily="2" charset="0"/>
+                <a:cs typeface="AKbalthom KhmerNew" panose="02000500000000000000" pitchFamily="2" charset="0"/>
+              </a:rPr>
+              <a:t> </a:t>
+            </a:r>
+            <a:r>
+              <a:rPr dirty="0" err="1">
+                <a:latin typeface="AKbalthom KhmerNew" panose="02000500000000000000" pitchFamily="2" charset="0"/>
+                <a:cs typeface="AKbalthom KhmerNew" panose="02000500000000000000" pitchFamily="2" charset="0"/>
+              </a:rPr>
+              <a:t>បង្ហាញការចែកចាយ</a:t>
+            </a:r>
+            <a:r>
+              <a:rPr dirty="0">
+                <a:latin typeface="AKbalthom KhmerNew" panose="02000500000000000000" pitchFamily="2" charset="0"/>
+                <a:cs typeface="AKbalthom KhmerNew" panose="02000500000000000000" pitchFamily="2" charset="0"/>
+              </a:rPr>
+              <a:t> nodes</a:t>
             </a:r>
           </a:p>
         </p:txBody>
@@ -5489,21 +5905,31 @@
               </a:defRPr>
             </a:pPr>
             <a:r>
-              <a:rPr>
+              <a:rPr dirty="0">
                 <a:latin typeface="AKbalthom KhmerNew" panose="02000500000000000000" pitchFamily="2" charset="0"/>
                 <a:cs typeface="AKbalthom KhmerNew" panose="02000500000000000000" pitchFamily="2" charset="0"/>
               </a:rPr>
               <a:t>✅  Official Deliverables: </a:t>
             </a:r>
             <a:r>
-              <a:rPr sz="1100" b="0">
+              <a:rPr sz="1100" b="0" dirty="0" err="1">
                 <a:solidFill>
                   <a:srgbClr val="F8FAFC"/>
                 </a:solidFill>
                 <a:latin typeface="AKbalthom KhmerNew" panose="02000500000000000000" pitchFamily="2" charset="0"/>
                 <a:cs typeface="AKbalthom KhmerNew" panose="02000500000000000000" pitchFamily="2" charset="0"/>
               </a:rPr>
-              <a:t>ឯកសារ REPORT.pdf (៤ ទំព័រ មានភស្តុតាងលម្អិត) &amp; REPORT.docx formatted reports</a:t>
+              <a:t>ឯកសារ</a:t>
+            </a:r>
+            <a:r>
+              <a:rPr sz="1100" b="0" dirty="0">
+                <a:solidFill>
+                  <a:srgbClr val="F8FAFC"/>
+                </a:solidFill>
+                <a:latin typeface="AKbalthom KhmerNew" panose="02000500000000000000" pitchFamily="2" charset="0"/>
+                <a:cs typeface="AKbalthom KhmerNew" panose="02000500000000000000" pitchFamily="2" charset="0"/>
+              </a:rPr>
+              <a:t> REPORT.pdf &amp; REPORT.docx formatted reports</a:t>
             </a:r>
           </a:p>
         </p:txBody>

</xml_diff>